<commit_message>
expand and add details to pptx presentations for mahasiswa 1 and 2
</commit_message>
<xml_diff>
--- a/0019_studi_kasus1_materi_4_khanin_oktavia.pptx
+++ b/0019_studi_kasus1_materi_4_khanin_oktavia.pptx
@@ -9,6 +9,7 @@
     <p:sldId id="257" r:id="rId4"/>
     <p:sldId id="266" r:id="rId5"/>
     <p:sldId id="267" r:id="rId6"/>
+    <p:sldId id="268" r:id="rId15"/>
     <p:sldId id="258" r:id="rId7"/>
   </p:sldIdLst>
   <p:sldSz cx="18288000" cy="10287000"/>
@@ -3881,7 +3882,7 @@
                 </a:solidFill>
                 <a:latin typeface="Inter"/>
               </a:rPr>
-              <a:t>Integrasi Data Relasional</a:t>
+              <a:t>Integrasi Data Transaksi</a:t>
             </a:r>
           </a:p>
         </p:txBody>
@@ -3920,7 +3921,7 @@
               </a:defRPr>
             </a:pPr>
             <a:r>
-              <a:t>Data Ingestion &amp; Merging: Mengintegrasikan tabel transaksi Olist (pelanggan, pesanan, item, dan pembayaran) menjadi satu dataset utuh.</a:t>
+              <a:t>Penggabungan Data: Mengintegrasikan tabel data olist (customers, orders, order_items, dan order_payments) menggunakan relasi kunci unik.</a:t>
             </a:r>
           </a:p>
           <a:p>
@@ -3936,55 +3937,7 @@
               </a:defRPr>
             </a:pPr>
             <a:r>
-              <a:t>RFM Engineering: Membuat metrik RFM untuk setiap pelanggan unik:</a:t>
-            </a:r>
-          </a:p>
-          <a:p>
-            <a:pPr lvl="1">
-              <a:spcAft>
-                <a:spcPts val="1200"/>
-              </a:spcAft>
-              <a:defRPr sz="2400">
-                <a:solidFill>
-                  <a:srgbClr val="403E3E"/>
-                </a:solidFill>
-                <a:latin typeface="Inter"/>
-              </a:defRPr>
-            </a:pPr>
-            <a:r>
-              <a:t>- Recency: Hari sejak transaksi terakhir.</a:t>
-            </a:r>
-          </a:p>
-          <a:p>
-            <a:pPr lvl="1">
-              <a:spcAft>
-                <a:spcPts val="1200"/>
-              </a:spcAft>
-              <a:defRPr sz="2400">
-                <a:solidFill>
-                  <a:srgbClr val="403E3E"/>
-                </a:solidFill>
-                <a:latin typeface="Inter"/>
-              </a:defRPr>
-            </a:pPr>
-            <a:r>
-              <a:t>- Frequency: Jumlah pesanan yang diselesaikan.</a:t>
-            </a:r>
-          </a:p>
-          <a:p>
-            <a:pPr lvl="1">
-              <a:spcAft>
-                <a:spcPts val="1200"/>
-              </a:spcAft>
-              <a:defRPr sz="2400">
-                <a:solidFill>
-                  <a:srgbClr val="403E3E"/>
-                </a:solidFill>
-                <a:latin typeface="Inter"/>
-              </a:defRPr>
-            </a:pPr>
-            <a:r>
-              <a:t>- Monetary: Total pengeluaran uang belanja.</a:t>
+              <a:t>Pbersihan Awal: Menyaring data transaksi yang sukses (status delivered atau invoiced) dan menghapus data tanpa pembayaran valid.</a:t>
             </a:r>
           </a:p>
           <a:p>
@@ -4000,7 +3953,7 @@
               </a:defRPr>
             </a:pPr>
             <a:r>
-              <a:t>Hasil: Diperoleh profil transaksi RFM untuk 93.358 pelanggan unik.</a:t>
+              <a:t>Hasil Integrasi: Menyatukan data mentah transaksional menjadi satu dataset pelanggan terpadu.</a:t>
             </a:r>
           </a:p>
         </p:txBody>
@@ -4313,7 +4266,7 @@
                 </a:solidFill>
                 <a:latin typeface="Inter"/>
               </a:rPr>
-              <a:t>Pembersihan &amp; Transformasi</a:t>
+              <a:t>Pembuatan Fitur RFM</a:t>
             </a:r>
           </a:p>
         </p:txBody>
@@ -4352,7 +4305,55 @@
               </a:defRPr>
             </a:pPr>
             <a:r>
-              <a:t>Penyaringan Outlier: Membuang pencilan transaksi ekstrim (di luar kuantil 5% s.d. 95%) agar kluster tidak bias oleh pelanggan anomali.</a:t>
+              <a:t>Rekayasa Fitur Segmentasi:</a:t>
+            </a:r>
+          </a:p>
+          <a:p>
+            <a:pPr lvl="1">
+              <a:spcAft>
+                <a:spcPts val="1200"/>
+              </a:spcAft>
+              <a:defRPr sz="2400">
+                <a:solidFill>
+                  <a:srgbClr val="403E3E"/>
+                </a:solidFill>
+                <a:latin typeface="Inter"/>
+              </a:defRPr>
+            </a:pPr>
+            <a:r>
+              <a:t>- Recency (R): Jumlah hari sejak transaksi terakhir pelanggan hingga tanggal analisis terakhir.</a:t>
+            </a:r>
+          </a:p>
+          <a:p>
+            <a:pPr lvl="1">
+              <a:spcAft>
+                <a:spcPts val="1200"/>
+              </a:spcAft>
+              <a:defRPr sz="2400">
+                <a:solidFill>
+                  <a:srgbClr val="403E3E"/>
+                </a:solidFill>
+                <a:latin typeface="Inter"/>
+              </a:defRPr>
+            </a:pPr>
+            <a:r>
+              <a:t>- Frequency (F): Total jumlah pesanan unik yang diselesaikan oleh setiap pelanggan.</a:t>
+            </a:r>
+          </a:p>
+          <a:p>
+            <a:pPr lvl="1">
+              <a:spcAft>
+                <a:spcPts val="1200"/>
+              </a:spcAft>
+              <a:defRPr sz="2400">
+                <a:solidFill>
+                  <a:srgbClr val="403E3E"/>
+                </a:solidFill>
+                <a:latin typeface="Inter"/>
+              </a:defRPr>
+            </a:pPr>
+            <a:r>
+              <a:t>- Monetary (M): Akumulasi nominal uang yang dibelanjakan oleh pelanggan selama masa keanggotaan.</a:t>
             </a:r>
           </a:p>
           <a:p>
@@ -4368,23 +4369,7 @@
               </a:defRPr>
             </a:pPr>
             <a:r>
-              <a:t>Feature Scaling: Menerapkan StandardScaler pada metrik RFM.</a:t>
-            </a:r>
-          </a:p>
-          <a:p>
-            <a:pPr>
-              <a:spcAft>
-                <a:spcPts val="1200"/>
-              </a:spcAft>
-              <a:defRPr sz="2800">
-                <a:solidFill>
-                  <a:srgbClr val="403E3E"/>
-                </a:solidFill>
-                <a:latin typeface="Inter"/>
-              </a:defRPr>
-            </a:pPr>
-            <a:r>
-              <a:t>Justifikasi: Penskalaan fitur sangat krusial karena algoritma clustering berbasis jarak (Euclidean) sangat sensitif terhadap perbedaan satuan data.</a:t>
+              <a:t>Hasil Profiling: Berhasil merangkum aktivitas belanja untuk 93.358 pelanggan unik.</a:t>
             </a:r>
           </a:p>
         </p:txBody>
@@ -4697,7 +4682,7 @@
                 </a:solidFill>
                 <a:latin typeface="Inter"/>
               </a:rPr>
-              <a:t>Optimasi Nilai K (Elbow)</a:t>
+              <a:t>Outlier &amp; Penskalaan RFM</a:t>
             </a:r>
           </a:p>
         </p:txBody>
@@ -4736,7 +4721,7 @@
               </a:defRPr>
             </a:pPr>
             <a:r>
-              <a:t>Metode Elbow: Menghitung nilai inersia (Sum of Squared Errors) untuk rentang kluster K = 2 s.d. K = 8 pada sampel data.</a:t>
+              <a:t>Penyaringan Pencilan: Menghapus pelanggan dengan nilai pembelian sangat ekstrem (di luar kuantil 5% s.d. 95%) agar kluster tidak bias oleh anomali reseller.</a:t>
             </a:r>
           </a:p>
           <a:p>
@@ -4752,7 +4737,7 @@
               </a:defRPr>
             </a:pPr>
             <a:r>
-              <a:t>Hasil Grafik Elbow: Penurunan nilai inersia melambat secara signifikan pada titik K = 4 (titik siku-siku).</a:t>
+              <a:t>Feature Scaling: Menerapkan StandardScaler pada variabel R, F, dan M untuk menyamakan rentang nilai.</a:t>
             </a:r>
           </a:p>
           <a:p>
@@ -4768,7 +4753,7 @@
               </a:defRPr>
             </a:pPr>
             <a:r>
-              <a:t>Kesimpulan: Jumlah kluster optimal yang direkomendasikan untuk segmentasi pelanggan Olist adalah K = 4.</a:t>
+              <a:t>Justifikasi: Algoritma klustering berbasis jarak (jarak Euclidean) sangat sensitif terhadap satuan data yang timpang (Monetary ribuan vs Frequency satuan).</a:t>
             </a:r>
           </a:p>
         </p:txBody>
@@ -4782,6 +4767,391 @@
 </file>
 
 <file path=ppt/slides/slide5.xml><?xml version="1.0" encoding="utf-8"?>
+<p:sld xmlns:a="http://schemas.openxmlformats.org/drawingml/2006/main" xmlns:p="http://schemas.openxmlformats.org/presentationml/2006/main" xmlns:r="http://schemas.openxmlformats.org/officeDocument/2006/relationships">
+  <p:cSld>
+    <p:spTree>
+      <p:nvGrpSpPr>
+        <p:cNvPr id="1" name=""/>
+        <p:cNvGrpSpPr/>
+        <p:nvPr/>
+      </p:nvGrpSpPr>
+      <p:grpSpPr/>
+      <p:grpSp>
+        <p:nvGrpSpPr>
+          <p:cNvPr id="2" name="Group 2"/>
+          <p:cNvGrpSpPr/>
+          <p:nvPr/>
+        </p:nvGrpSpPr>
+        <p:grpSpPr>
+          <a:xfrm rot="5400000">
+            <a:off x="12432431" y="4605338"/>
+            <a:ext cx="10730064" cy="1076325"/>
+            <a:chOff x="0" y="0"/>
+            <a:chExt cx="3845413" cy="385731"/>
+          </a:xfrm>
+        </p:grpSpPr>
+        <p:sp>
+          <p:nvSpPr>
+            <p:cNvPr id="3" name="Freeform 3"/>
+            <p:cNvSpPr/>
+            <p:nvPr/>
+          </p:nvSpPr>
+          <p:spPr>
+            <a:xfrm>
+              <a:off x="0" y="0"/>
+              <a:ext cx="3845413" cy="385731"/>
+            </a:xfrm>
+            <a:custGeom>
+              <a:avLst/>
+              <a:gdLst/>
+              <a:ahLst/>
+              <a:cxnLst/>
+              <a:rect l="l" t="t" r="r" b="b"/>
+              <a:pathLst>
+                <a:path w="3845413" h="385731">
+                  <a:moveTo>
+                    <a:pt x="0" y="0"/>
+                  </a:moveTo>
+                  <a:lnTo>
+                    <a:pt x="3845413" y="0"/>
+                  </a:lnTo>
+                  <a:lnTo>
+                    <a:pt x="3845413" y="385731"/>
+                  </a:lnTo>
+                  <a:lnTo>
+                    <a:pt x="0" y="385731"/>
+                  </a:lnTo>
+                  <a:close/>
+                </a:path>
+              </a:pathLst>
+            </a:custGeom>
+            <a:solidFill>
+              <a:srgbClr val="FDFDFA"/>
+            </a:solidFill>
+            <a:ln w="9525" cap="sq">
+              <a:solidFill>
+                <a:srgbClr val="403E3E"/>
+              </a:solidFill>
+              <a:prstDash val="solid"/>
+              <a:miter/>
+            </a:ln>
+          </p:spPr>
+        </p:sp>
+        <p:sp>
+          <p:nvSpPr>
+            <p:cNvPr id="4" name="TextBox 4"/>
+            <p:cNvSpPr txBox="1"/>
+            <p:nvPr/>
+          </p:nvSpPr>
+          <p:spPr>
+            <a:xfrm>
+              <a:off x="0" y="-47625"/>
+              <a:ext cx="3845413" cy="433356"/>
+            </a:xfrm>
+            <a:prstGeom prst="rect">
+              <a:avLst/>
+            </a:prstGeom>
+          </p:spPr>
+          <p:txBody>
+            <a:bodyPr lIns="50800" tIns="50800" rIns="50800" bIns="50800" rtlCol="0" anchor="ctr"/>
+            <a:lstStyle/>
+            <a:p>
+              <a:pPr algn="ctr">
+                <a:lnSpc>
+                  <a:spcPts val="1960"/>
+                </a:lnSpc>
+              </a:pPr>
+            </a:p>
+          </p:txBody>
+        </p:sp>
+      </p:grpSp>
+      <p:sp>
+        <p:nvSpPr>
+          <p:cNvPr id="9" name="TextBox 9"/>
+          <p:cNvSpPr txBox="1"/>
+          <p:nvPr/>
+        </p:nvSpPr>
+        <p:spPr>
+          <a:xfrm>
+            <a:off x="15506330" y="8951595"/>
+            <a:ext cx="152400" cy="190500"/>
+          </a:xfrm>
+          <a:prstGeom prst="rect">
+            <a:avLst/>
+          </a:prstGeom>
+        </p:spPr>
+        <p:txBody>
+          <a:bodyPr wrap="none" lIns="0" tIns="0" rIns="0" bIns="0" rtlCol="0" anchor="t">
+            <a:spAutoFit/>
+          </a:bodyPr>
+          <a:lstStyle/>
+          <a:p>
+            <a:r>
+              <a:rPr sz="1800">
+                <a:solidFill>
+                  <a:srgbClr val="403E3E"/>
+                </a:solidFill>
+                <a:latin typeface="Inter"/>
+              </a:rPr>
+              <a:t>PAGE 5</a:t>
+            </a:r>
+          </a:p>
+        </p:txBody>
+      </p:sp>
+      <p:grpSp>
+        <p:nvGrpSpPr>
+          <p:cNvPr id="15" name="Group 15"/>
+          <p:cNvGrpSpPr/>
+          <p:nvPr/>
+        </p:nvGrpSpPr>
+        <p:grpSpPr>
+          <a:xfrm rot="5400000">
+            <a:off x="-3195310" y="2727751"/>
+            <a:ext cx="10730064" cy="4831498"/>
+            <a:chOff x="0" y="0"/>
+            <a:chExt cx="3845413" cy="1731500"/>
+          </a:xfrm>
+        </p:grpSpPr>
+        <p:sp>
+          <p:nvSpPr>
+            <p:cNvPr id="16" name="Freeform 16"/>
+            <p:cNvSpPr/>
+            <p:nvPr/>
+          </p:nvSpPr>
+          <p:spPr>
+            <a:xfrm>
+              <a:off x="0" y="0"/>
+              <a:ext cx="3845413" cy="1731500"/>
+            </a:xfrm>
+            <a:custGeom>
+              <a:avLst/>
+              <a:gdLst/>
+              <a:ahLst/>
+              <a:cxnLst/>
+              <a:rect l="l" t="t" r="r" b="b"/>
+              <a:pathLst>
+                <a:path w="3845413" h="1731500">
+                  <a:moveTo>
+                    <a:pt x="0" y="0"/>
+                  </a:moveTo>
+                  <a:lnTo>
+                    <a:pt x="3845413" y="0"/>
+                  </a:lnTo>
+                  <a:lnTo>
+                    <a:pt x="3845413" y="1731500"/>
+                  </a:lnTo>
+                  <a:lnTo>
+                    <a:pt x="0" y="1731500"/>
+                  </a:lnTo>
+                  <a:close/>
+                </a:path>
+              </a:pathLst>
+            </a:custGeom>
+            <a:solidFill>
+              <a:srgbClr val="F6F5F3"/>
+            </a:solidFill>
+            <a:ln w="9525" cap="sq">
+              <a:solidFill>
+                <a:srgbClr val="403E3E"/>
+              </a:solidFill>
+              <a:prstDash val="solid"/>
+              <a:miter/>
+            </a:ln>
+          </p:spPr>
+        </p:sp>
+        <p:sp>
+          <p:nvSpPr>
+            <p:cNvPr id="17" name="TextBox 17"/>
+            <p:cNvSpPr txBox="1"/>
+            <p:nvPr/>
+          </p:nvSpPr>
+          <p:spPr>
+            <a:xfrm>
+              <a:off x="0" y="-47625"/>
+              <a:ext cx="3845413" cy="1779125"/>
+            </a:xfrm>
+            <a:prstGeom prst="rect">
+              <a:avLst/>
+            </a:prstGeom>
+          </p:spPr>
+          <p:txBody>
+            <a:bodyPr lIns="50800" tIns="50800" rIns="50800" bIns="50800" rtlCol="0" anchor="ctr"/>
+            <a:lstStyle/>
+            <a:p>
+              <a:pPr algn="ctr">
+                <a:lnSpc>
+                  <a:spcPts val="1960"/>
+                </a:lnSpc>
+              </a:pPr>
+            </a:p>
+          </p:txBody>
+        </p:sp>
+      </p:grpSp>
+      <p:sp>
+        <p:nvSpPr>
+          <p:cNvPr id="18" name="TextBox 17"/>
+          <p:cNvSpPr txBox="1"/>
+          <p:nvPr/>
+        </p:nvSpPr>
+        <p:spPr>
+          <a:xfrm>
+            <a:off x="90525" y="1028700"/>
+            <a:ext cx="8769096" cy="1354226"/>
+          </a:xfrm>
+          <a:prstGeom prst="rect">
+            <a:avLst/>
+          </a:prstGeom>
+          <a:noFill/>
+        </p:spPr>
+        <p:txBody>
+          <a:bodyPr wrap="square">
+            <a:spAutoFit/>
+          </a:bodyPr>
+          <a:lstStyle/>
+          <a:p>
+            <a:r>
+              <a:rPr sz="4400" b="0" i="0">
+                <a:solidFill>
+                  <a:srgbClr val="403E3E"/>
+                </a:solidFill>
+                <a:latin typeface="Inter"/>
+              </a:rPr>
+              <a:t>Tahap Data
+   Engineering</a:t>
+            </a:r>
+          </a:p>
+        </p:txBody>
+      </p:sp>
+      <p:sp>
+        <p:nvSpPr>
+          <p:cNvPr id="19" name="TextBox 18"/>
+          <p:cNvSpPr txBox="1"/>
+          <p:nvPr/>
+        </p:nvSpPr>
+        <p:spPr>
+          <a:xfrm>
+            <a:off x="457200" y="3161995"/>
+            <a:ext cx="3994099" cy="2708452"/>
+          </a:xfrm>
+          <a:prstGeom prst="rect">
+            <a:avLst/>
+          </a:prstGeom>
+          <a:noFill/>
+        </p:spPr>
+        <p:txBody>
+          <a:bodyPr wrap="square">
+            <a:spAutoFit/>
+          </a:bodyPr>
+          <a:lstStyle/>
+          <a:p>
+            <a:r>
+              <a:rPr sz="4400" b="0" i="0">
+                <a:solidFill>
+                  <a:srgbClr val="403E3E"/>
+                </a:solidFill>
+                <a:latin typeface="Inter"/>
+              </a:rPr>
+              <a:t>Optimasi K (Metode Elbow)</a:t>
+            </a:r>
+          </a:p>
+        </p:txBody>
+      </p:sp>
+      <p:sp>
+        <p:nvSpPr>
+          <p:cNvPr id="20" name="TextBox 19"/>
+          <p:cNvSpPr txBox="1"/>
+          <p:nvPr/>
+        </p:nvSpPr>
+        <p:spPr>
+          <a:xfrm>
+            <a:off x="5410504" y="1028700"/>
+            <a:ext cx="12401092" cy="7755940"/>
+          </a:xfrm>
+          <a:prstGeom prst="rect">
+            <a:avLst/>
+          </a:prstGeom>
+          <a:noFill/>
+        </p:spPr>
+        <p:txBody>
+          <a:bodyPr wrap="square">
+            <a:spAutoFit/>
+          </a:bodyPr>
+          <a:lstStyle/>
+          <a:p>
+            <a:pPr>
+              <a:spcAft>
+                <a:spcPts val="1200"/>
+              </a:spcAft>
+              <a:defRPr sz="2800">
+                <a:solidFill>
+                  <a:srgbClr val="403E3E"/>
+                </a:solidFill>
+                <a:latin typeface="Inter"/>
+              </a:defRPr>
+            </a:pPr>
+            <a:r>
+              <a:t>Evaluasi K: Menguji jumlah kluster optimal K dari rentang 2 hingga 8 menggunakan sum sampel data.</a:t>
+            </a:r>
+          </a:p>
+          <a:p>
+            <a:pPr>
+              <a:spcAft>
+                <a:spcPts val="1200"/>
+              </a:spcAft>
+              <a:defRPr sz="2800">
+                <a:solidFill>
+                  <a:srgbClr val="403E3E"/>
+                </a:solidFill>
+                <a:latin typeface="Inter"/>
+              </a:defRPr>
+            </a:pPr>
+            <a:r>
+              <a:t>Inersia (SSE): Menghitung jumlah kuadrat jarak kesalahan (Sum of Squared Errors) untuk setiap nilai K.</a:t>
+            </a:r>
+          </a:p>
+          <a:p>
+            <a:pPr>
+              <a:spcAft>
+                <a:spcPts val="1200"/>
+              </a:spcAft>
+              <a:defRPr sz="2800">
+                <a:solidFill>
+                  <a:srgbClr val="403E3E"/>
+                </a:solidFill>
+                <a:latin typeface="Inter"/>
+              </a:defRPr>
+            </a:pPr>
+            <a:r>
+              <a:t>Hasil Titik Siku: Grafik inersia melandai secara signifikan (infleksi/elbow) pada titik K = 4.</a:t>
+            </a:r>
+          </a:p>
+          <a:p>
+            <a:pPr>
+              <a:spcAft>
+                <a:spcPts val="1200"/>
+              </a:spcAft>
+              <a:defRPr sz="2800">
+                <a:solidFill>
+                  <a:srgbClr val="403E3E"/>
+                </a:solidFill>
+                <a:latin typeface="Inter"/>
+              </a:defRPr>
+            </a:pPr>
+            <a:r>
+              <a:t>Kesimpulan: Jumlah segmen optimal untuk segmentasi pelanggan Olist ditetapkan sebanyak K = 4 kluster.</a:t>
+            </a:r>
+          </a:p>
+        </p:txBody>
+      </p:sp>
+    </p:spTree>
+  </p:cSld>
+  <p:clrMapOvr>
+    <a:masterClrMapping/>
+  </p:clrMapOvr>
+</p:sld>
+</file>
+
+<file path=ppt/slides/slide6.xml><?xml version="1.0" encoding="utf-8"?>
 <p:sld xmlns:a="http://schemas.openxmlformats.org/drawingml/2006/main" xmlns:r="http://schemas.openxmlformats.org/officeDocument/2006/relationships" xmlns:p="http://schemas.openxmlformats.org/presentationml/2006/main">
   <p:cSld>
     <p:bg>

</xml_diff>